<commit_message>
Update 163 HE JESOSY TOKINTSIKA.pptx
</commit_message>
<xml_diff>
--- a/data/FFPM/163 HE JESOSY TOKINTSIKA.pptx
+++ b/data/FFPM/163 HE JESOSY TOKINTSIKA.pptx
@@ -109,6 +109,22 @@
       </a:defRPr>
     </a:lvl9pPr>
   </p:defaultTextStyle>
+  <p:extLst>
+    <p:ext uri="{EFAFB233-063F-42B5-8137-9DF3F51BA10A}">
+      <p15:sldGuideLst xmlns:p15="http://schemas.microsoft.com/office/powerpoint/2012/main">
+        <p15:guide id="1" orient="horz" pos="2160">
+          <p15:clr>
+            <a:srgbClr val="A4A3A4"/>
+          </p15:clr>
+        </p15:guide>
+        <p15:guide id="2" pos="2880">
+          <p15:clr>
+            <a:srgbClr val="A4A3A4"/>
+          </p15:clr>
+        </p15:guide>
+      </p15:sldGuideLst>
+    </p:ext>
+  </p:extLst>
 </p:presentation>
 </file>
 
@@ -150,7 +166,7 @@
           <a:lstStyle/>
           <a:p>
             <a:r>
-              <a:rPr lang="fr-FR" smtClean="0"/>
+              <a:rPr lang="fr-FR"/>
               <a:t>Cliquez pour modifier le style du titre</a:t>
             </a:r>
             <a:endParaRPr lang="fr-BE"/>
@@ -269,7 +285,7 @@
           </a:lstStyle>
           <a:p>
             <a:r>
-              <a:rPr lang="fr-FR" smtClean="0"/>
+              <a:rPr lang="fr-FR"/>
               <a:t>Cliquez pour modifier le style des sous-titres du masque</a:t>
             </a:r>
             <a:endParaRPr lang="fr-BE"/>
@@ -294,7 +310,7 @@
             <a:fld id="{AA309A6D-C09C-4548-B29A-6CF363A7E532}" type="datetimeFigureOut">
               <a:rPr lang="fr-FR" smtClean="0"/>
               <a:pPr/>
-              <a:t>25/07/2013</a:t>
+              <a:t>02/08/2025</a:t>
             </a:fld>
             <a:endParaRPr lang="fr-BE"/>
           </a:p>
@@ -384,7 +400,7 @@
           <a:lstStyle/>
           <a:p>
             <a:r>
-              <a:rPr lang="fr-FR" smtClean="0"/>
+              <a:rPr lang="fr-FR"/>
               <a:t>Cliquez pour modifier le style du titre</a:t>
             </a:r>
             <a:endParaRPr lang="fr-BE"/>
@@ -408,35 +424,35 @@
           <a:p>
             <a:pPr lvl="0"/>
             <a:r>
-              <a:rPr lang="fr-FR" smtClean="0"/>
+              <a:rPr lang="fr-FR"/>
               <a:t>Cliquez pour modifier les styles du texte du masque</a:t>
             </a:r>
           </a:p>
           <a:p>
             <a:pPr lvl="1"/>
             <a:r>
-              <a:rPr lang="fr-FR" smtClean="0"/>
+              <a:rPr lang="fr-FR"/>
               <a:t>Deuxième niveau</a:t>
             </a:r>
           </a:p>
           <a:p>
             <a:pPr lvl="2"/>
             <a:r>
-              <a:rPr lang="fr-FR" smtClean="0"/>
+              <a:rPr lang="fr-FR"/>
               <a:t>Troisième niveau</a:t>
             </a:r>
           </a:p>
           <a:p>
             <a:pPr lvl="3"/>
             <a:r>
-              <a:rPr lang="fr-FR" smtClean="0"/>
+              <a:rPr lang="fr-FR"/>
               <a:t>Quatrième niveau</a:t>
             </a:r>
           </a:p>
           <a:p>
             <a:pPr lvl="4"/>
             <a:r>
-              <a:rPr lang="fr-FR" smtClean="0"/>
+              <a:rPr lang="fr-FR"/>
               <a:t>Cinquième niveau</a:t>
             </a:r>
             <a:endParaRPr lang="fr-BE"/>
@@ -461,7 +477,7 @@
             <a:fld id="{AA309A6D-C09C-4548-B29A-6CF363A7E532}" type="datetimeFigureOut">
               <a:rPr lang="fr-FR" smtClean="0"/>
               <a:pPr/>
-              <a:t>25/07/2013</a:t>
+              <a:t>02/08/2025</a:t>
             </a:fld>
             <a:endParaRPr lang="fr-BE"/>
           </a:p>
@@ -556,7 +572,7 @@
           <a:lstStyle/>
           <a:p>
             <a:r>
-              <a:rPr lang="fr-FR" smtClean="0"/>
+              <a:rPr lang="fr-FR"/>
               <a:t>Cliquez pour modifier le style du titre</a:t>
             </a:r>
             <a:endParaRPr lang="fr-BE"/>
@@ -585,35 +601,35 @@
           <a:p>
             <a:pPr lvl="0"/>
             <a:r>
-              <a:rPr lang="fr-FR" smtClean="0"/>
+              <a:rPr lang="fr-FR"/>
               <a:t>Cliquez pour modifier les styles du texte du masque</a:t>
             </a:r>
           </a:p>
           <a:p>
             <a:pPr lvl="1"/>
             <a:r>
-              <a:rPr lang="fr-FR" smtClean="0"/>
+              <a:rPr lang="fr-FR"/>
               <a:t>Deuxième niveau</a:t>
             </a:r>
           </a:p>
           <a:p>
             <a:pPr lvl="2"/>
             <a:r>
-              <a:rPr lang="fr-FR" smtClean="0"/>
+              <a:rPr lang="fr-FR"/>
               <a:t>Troisième niveau</a:t>
             </a:r>
           </a:p>
           <a:p>
             <a:pPr lvl="3"/>
             <a:r>
-              <a:rPr lang="fr-FR" smtClean="0"/>
+              <a:rPr lang="fr-FR"/>
               <a:t>Quatrième niveau</a:t>
             </a:r>
           </a:p>
           <a:p>
             <a:pPr lvl="4"/>
             <a:r>
-              <a:rPr lang="fr-FR" smtClean="0"/>
+              <a:rPr lang="fr-FR"/>
               <a:t>Cinquième niveau</a:t>
             </a:r>
             <a:endParaRPr lang="fr-BE"/>
@@ -638,7 +654,7 @@
             <a:fld id="{AA309A6D-C09C-4548-B29A-6CF363A7E532}" type="datetimeFigureOut">
               <a:rPr lang="fr-FR" smtClean="0"/>
               <a:pPr/>
-              <a:t>25/07/2013</a:t>
+              <a:t>02/08/2025</a:t>
             </a:fld>
             <a:endParaRPr lang="fr-BE"/>
           </a:p>
@@ -728,7 +744,7 @@
           <a:lstStyle/>
           <a:p>
             <a:r>
-              <a:rPr lang="fr-FR" smtClean="0"/>
+              <a:rPr lang="fr-FR"/>
               <a:t>Cliquez pour modifier le style du titre</a:t>
             </a:r>
             <a:endParaRPr lang="fr-BE"/>
@@ -752,35 +768,35 @@
           <a:p>
             <a:pPr lvl="0"/>
             <a:r>
-              <a:rPr lang="fr-FR" smtClean="0"/>
+              <a:rPr lang="fr-FR"/>
               <a:t>Cliquez pour modifier les styles du texte du masque</a:t>
             </a:r>
           </a:p>
           <a:p>
             <a:pPr lvl="1"/>
             <a:r>
-              <a:rPr lang="fr-FR" smtClean="0"/>
+              <a:rPr lang="fr-FR"/>
               <a:t>Deuxième niveau</a:t>
             </a:r>
           </a:p>
           <a:p>
             <a:pPr lvl="2"/>
             <a:r>
-              <a:rPr lang="fr-FR" smtClean="0"/>
+              <a:rPr lang="fr-FR"/>
               <a:t>Troisième niveau</a:t>
             </a:r>
           </a:p>
           <a:p>
             <a:pPr lvl="3"/>
             <a:r>
-              <a:rPr lang="fr-FR" smtClean="0"/>
+              <a:rPr lang="fr-FR"/>
               <a:t>Quatrième niveau</a:t>
             </a:r>
           </a:p>
           <a:p>
             <a:pPr lvl="4"/>
             <a:r>
-              <a:rPr lang="fr-FR" smtClean="0"/>
+              <a:rPr lang="fr-FR"/>
               <a:t>Cinquième niveau</a:t>
             </a:r>
             <a:endParaRPr lang="fr-BE"/>
@@ -805,7 +821,7 @@
             <a:fld id="{AA309A6D-C09C-4548-B29A-6CF363A7E532}" type="datetimeFigureOut">
               <a:rPr lang="fr-FR" smtClean="0"/>
               <a:pPr/>
-              <a:t>25/07/2013</a:t>
+              <a:t>02/08/2025</a:t>
             </a:fld>
             <a:endParaRPr lang="fr-BE"/>
           </a:p>
@@ -904,7 +920,7 @@
           </a:lstStyle>
           <a:p>
             <a:r>
-              <a:rPr lang="fr-FR" smtClean="0"/>
+              <a:rPr lang="fr-FR"/>
               <a:t>Cliquez pour modifier le style du titre</a:t>
             </a:r>
             <a:endParaRPr lang="fr-BE"/>
@@ -1024,7 +1040,7 @@
           <a:p>
             <a:pPr lvl="0"/>
             <a:r>
-              <a:rPr lang="fr-FR" smtClean="0"/>
+              <a:rPr lang="fr-FR"/>
               <a:t>Cliquez pour modifier les styles du texte du masque</a:t>
             </a:r>
           </a:p>
@@ -1048,7 +1064,7 @@
             <a:fld id="{AA309A6D-C09C-4548-B29A-6CF363A7E532}" type="datetimeFigureOut">
               <a:rPr lang="fr-FR" smtClean="0"/>
               <a:pPr/>
-              <a:t>25/07/2013</a:t>
+              <a:t>02/08/2025</a:t>
             </a:fld>
             <a:endParaRPr lang="fr-BE"/>
           </a:p>
@@ -1138,7 +1154,7 @@
           <a:lstStyle/>
           <a:p>
             <a:r>
-              <a:rPr lang="fr-FR" smtClean="0"/>
+              <a:rPr lang="fr-FR"/>
               <a:t>Cliquez pour modifier le style du titre</a:t>
             </a:r>
             <a:endParaRPr lang="fr-BE"/>
@@ -1195,35 +1211,35 @@
           <a:p>
             <a:pPr lvl="0"/>
             <a:r>
-              <a:rPr lang="fr-FR" smtClean="0"/>
+              <a:rPr lang="fr-FR"/>
               <a:t>Cliquez pour modifier les styles du texte du masque</a:t>
             </a:r>
           </a:p>
           <a:p>
             <a:pPr lvl="1"/>
             <a:r>
-              <a:rPr lang="fr-FR" smtClean="0"/>
+              <a:rPr lang="fr-FR"/>
               <a:t>Deuxième niveau</a:t>
             </a:r>
           </a:p>
           <a:p>
             <a:pPr lvl="2"/>
             <a:r>
-              <a:rPr lang="fr-FR" smtClean="0"/>
+              <a:rPr lang="fr-FR"/>
               <a:t>Troisième niveau</a:t>
             </a:r>
           </a:p>
           <a:p>
             <a:pPr lvl="3"/>
             <a:r>
-              <a:rPr lang="fr-FR" smtClean="0"/>
+              <a:rPr lang="fr-FR"/>
               <a:t>Quatrième niveau</a:t>
             </a:r>
           </a:p>
           <a:p>
             <a:pPr lvl="4"/>
             <a:r>
-              <a:rPr lang="fr-FR" smtClean="0"/>
+              <a:rPr lang="fr-FR"/>
               <a:t>Cinquième niveau</a:t>
             </a:r>
             <a:endParaRPr lang="fr-BE"/>
@@ -1280,35 +1296,35 @@
           <a:p>
             <a:pPr lvl="0"/>
             <a:r>
-              <a:rPr lang="fr-FR" smtClean="0"/>
+              <a:rPr lang="fr-FR"/>
               <a:t>Cliquez pour modifier les styles du texte du masque</a:t>
             </a:r>
           </a:p>
           <a:p>
             <a:pPr lvl="1"/>
             <a:r>
-              <a:rPr lang="fr-FR" smtClean="0"/>
+              <a:rPr lang="fr-FR"/>
               <a:t>Deuxième niveau</a:t>
             </a:r>
           </a:p>
           <a:p>
             <a:pPr lvl="2"/>
             <a:r>
-              <a:rPr lang="fr-FR" smtClean="0"/>
+              <a:rPr lang="fr-FR"/>
               <a:t>Troisième niveau</a:t>
             </a:r>
           </a:p>
           <a:p>
             <a:pPr lvl="3"/>
             <a:r>
-              <a:rPr lang="fr-FR" smtClean="0"/>
+              <a:rPr lang="fr-FR"/>
               <a:t>Quatrième niveau</a:t>
             </a:r>
           </a:p>
           <a:p>
             <a:pPr lvl="4"/>
             <a:r>
-              <a:rPr lang="fr-FR" smtClean="0"/>
+              <a:rPr lang="fr-FR"/>
               <a:t>Cinquième niveau</a:t>
             </a:r>
             <a:endParaRPr lang="fr-BE"/>
@@ -1333,7 +1349,7 @@
             <a:fld id="{AA309A6D-C09C-4548-B29A-6CF363A7E532}" type="datetimeFigureOut">
               <a:rPr lang="fr-FR" smtClean="0"/>
               <a:pPr/>
-              <a:t>25/07/2013</a:t>
+              <a:t>02/08/2025</a:t>
             </a:fld>
             <a:endParaRPr lang="fr-BE"/>
           </a:p>
@@ -1427,7 +1443,7 @@
           </a:lstStyle>
           <a:p>
             <a:r>
-              <a:rPr lang="fr-FR" smtClean="0"/>
+              <a:rPr lang="fr-FR"/>
               <a:t>Cliquez pour modifier le style du titre</a:t>
             </a:r>
             <a:endParaRPr lang="fr-BE"/>
@@ -1493,7 +1509,7 @@
           <a:p>
             <a:pPr lvl="0"/>
             <a:r>
-              <a:rPr lang="fr-FR" smtClean="0"/>
+              <a:rPr lang="fr-FR"/>
               <a:t>Cliquez pour modifier les styles du texte du masque</a:t>
             </a:r>
           </a:p>
@@ -1549,35 +1565,35 @@
           <a:p>
             <a:pPr lvl="0"/>
             <a:r>
-              <a:rPr lang="fr-FR" smtClean="0"/>
+              <a:rPr lang="fr-FR"/>
               <a:t>Cliquez pour modifier les styles du texte du masque</a:t>
             </a:r>
           </a:p>
           <a:p>
             <a:pPr lvl="1"/>
             <a:r>
-              <a:rPr lang="fr-FR" smtClean="0"/>
+              <a:rPr lang="fr-FR"/>
               <a:t>Deuxième niveau</a:t>
             </a:r>
           </a:p>
           <a:p>
             <a:pPr lvl="2"/>
             <a:r>
-              <a:rPr lang="fr-FR" smtClean="0"/>
+              <a:rPr lang="fr-FR"/>
               <a:t>Troisième niveau</a:t>
             </a:r>
           </a:p>
           <a:p>
             <a:pPr lvl="3"/>
             <a:r>
-              <a:rPr lang="fr-FR" smtClean="0"/>
+              <a:rPr lang="fr-FR"/>
               <a:t>Quatrième niveau</a:t>
             </a:r>
           </a:p>
           <a:p>
             <a:pPr lvl="4"/>
             <a:r>
-              <a:rPr lang="fr-FR" smtClean="0"/>
+              <a:rPr lang="fr-FR"/>
               <a:t>Cinquième niveau</a:t>
             </a:r>
             <a:endParaRPr lang="fr-BE"/>
@@ -1643,7 +1659,7 @@
           <a:p>
             <a:pPr lvl="0"/>
             <a:r>
-              <a:rPr lang="fr-FR" smtClean="0"/>
+              <a:rPr lang="fr-FR"/>
               <a:t>Cliquez pour modifier les styles du texte du masque</a:t>
             </a:r>
           </a:p>
@@ -1699,35 +1715,35 @@
           <a:p>
             <a:pPr lvl="0"/>
             <a:r>
-              <a:rPr lang="fr-FR" smtClean="0"/>
+              <a:rPr lang="fr-FR"/>
               <a:t>Cliquez pour modifier les styles du texte du masque</a:t>
             </a:r>
           </a:p>
           <a:p>
             <a:pPr lvl="1"/>
             <a:r>
-              <a:rPr lang="fr-FR" smtClean="0"/>
+              <a:rPr lang="fr-FR"/>
               <a:t>Deuxième niveau</a:t>
             </a:r>
           </a:p>
           <a:p>
             <a:pPr lvl="2"/>
             <a:r>
-              <a:rPr lang="fr-FR" smtClean="0"/>
+              <a:rPr lang="fr-FR"/>
               <a:t>Troisième niveau</a:t>
             </a:r>
           </a:p>
           <a:p>
             <a:pPr lvl="3"/>
             <a:r>
-              <a:rPr lang="fr-FR" smtClean="0"/>
+              <a:rPr lang="fr-FR"/>
               <a:t>Quatrième niveau</a:t>
             </a:r>
           </a:p>
           <a:p>
             <a:pPr lvl="4"/>
             <a:r>
-              <a:rPr lang="fr-FR" smtClean="0"/>
+              <a:rPr lang="fr-FR"/>
               <a:t>Cinquième niveau</a:t>
             </a:r>
             <a:endParaRPr lang="fr-BE"/>
@@ -1752,7 +1768,7 @@
             <a:fld id="{AA309A6D-C09C-4548-B29A-6CF363A7E532}" type="datetimeFigureOut">
               <a:rPr lang="fr-FR" smtClean="0"/>
               <a:pPr/>
-              <a:t>25/07/2013</a:t>
+              <a:t>02/08/2025</a:t>
             </a:fld>
             <a:endParaRPr lang="fr-BE"/>
           </a:p>
@@ -1842,7 +1858,7 @@
           <a:lstStyle/>
           <a:p>
             <a:r>
-              <a:rPr lang="fr-FR" smtClean="0"/>
+              <a:rPr lang="fr-FR"/>
               <a:t>Cliquez pour modifier le style du titre</a:t>
             </a:r>
             <a:endParaRPr lang="fr-BE"/>
@@ -1867,7 +1883,7 @@
             <a:fld id="{AA309A6D-C09C-4548-B29A-6CF363A7E532}" type="datetimeFigureOut">
               <a:rPr lang="fr-FR" smtClean="0"/>
               <a:pPr/>
-              <a:t>25/07/2013</a:t>
+              <a:t>02/08/2025</a:t>
             </a:fld>
             <a:endParaRPr lang="fr-BE"/>
           </a:p>
@@ -1959,7 +1975,7 @@
             <a:fld id="{AA309A6D-C09C-4548-B29A-6CF363A7E532}" type="datetimeFigureOut">
               <a:rPr lang="fr-FR" smtClean="0"/>
               <a:pPr/>
-              <a:t>25/07/2013</a:t>
+              <a:t>02/08/2025</a:t>
             </a:fld>
             <a:endParaRPr lang="fr-BE"/>
           </a:p>
@@ -2058,7 +2074,7 @@
           </a:lstStyle>
           <a:p>
             <a:r>
-              <a:rPr lang="fr-FR" smtClean="0"/>
+              <a:rPr lang="fr-FR"/>
               <a:t>Cliquez pour modifier le style du titre</a:t>
             </a:r>
             <a:endParaRPr lang="fr-BE"/>
@@ -2115,35 +2131,35 @@
           <a:p>
             <a:pPr lvl="0"/>
             <a:r>
-              <a:rPr lang="fr-FR" smtClean="0"/>
+              <a:rPr lang="fr-FR"/>
               <a:t>Cliquez pour modifier les styles du texte du masque</a:t>
             </a:r>
           </a:p>
           <a:p>
             <a:pPr lvl="1"/>
             <a:r>
-              <a:rPr lang="fr-FR" smtClean="0"/>
+              <a:rPr lang="fr-FR"/>
               <a:t>Deuxième niveau</a:t>
             </a:r>
           </a:p>
           <a:p>
             <a:pPr lvl="2"/>
             <a:r>
-              <a:rPr lang="fr-FR" smtClean="0"/>
+              <a:rPr lang="fr-FR"/>
               <a:t>Troisième niveau</a:t>
             </a:r>
           </a:p>
           <a:p>
             <a:pPr lvl="3"/>
             <a:r>
-              <a:rPr lang="fr-FR" smtClean="0"/>
+              <a:rPr lang="fr-FR"/>
               <a:t>Quatrième niveau</a:t>
             </a:r>
           </a:p>
           <a:p>
             <a:pPr lvl="4"/>
             <a:r>
-              <a:rPr lang="fr-FR" smtClean="0"/>
+              <a:rPr lang="fr-FR"/>
               <a:t>Cinquième niveau</a:t>
             </a:r>
             <a:endParaRPr lang="fr-BE"/>
@@ -2209,7 +2225,7 @@
           <a:p>
             <a:pPr lvl="0"/>
             <a:r>
-              <a:rPr lang="fr-FR" smtClean="0"/>
+              <a:rPr lang="fr-FR"/>
               <a:t>Cliquez pour modifier les styles du texte du masque</a:t>
             </a:r>
           </a:p>
@@ -2233,7 +2249,7 @@
             <a:fld id="{AA309A6D-C09C-4548-B29A-6CF363A7E532}" type="datetimeFigureOut">
               <a:rPr lang="fr-FR" smtClean="0"/>
               <a:pPr/>
-              <a:t>25/07/2013</a:t>
+              <a:t>02/08/2025</a:t>
             </a:fld>
             <a:endParaRPr lang="fr-BE"/>
           </a:p>
@@ -2332,7 +2348,7 @@
           </a:lstStyle>
           <a:p>
             <a:r>
-              <a:rPr lang="fr-FR" smtClean="0"/>
+              <a:rPr lang="fr-FR"/>
               <a:t>Cliquez pour modifier le style du titre</a:t>
             </a:r>
             <a:endParaRPr lang="fr-BE"/>
@@ -2459,7 +2475,7 @@
           <a:p>
             <a:pPr lvl="0"/>
             <a:r>
-              <a:rPr lang="fr-FR" smtClean="0"/>
+              <a:rPr lang="fr-FR"/>
               <a:t>Cliquez pour modifier les styles du texte du masque</a:t>
             </a:r>
           </a:p>
@@ -2483,7 +2499,7 @@
             <a:fld id="{AA309A6D-C09C-4548-B29A-6CF363A7E532}" type="datetimeFigureOut">
               <a:rPr lang="fr-FR" smtClean="0"/>
               <a:pPr/>
-              <a:t>25/07/2013</a:t>
+              <a:t>02/08/2025</a:t>
             </a:fld>
             <a:endParaRPr lang="fr-BE"/>
           </a:p>
@@ -2588,7 +2604,7 @@
           <a:lstStyle/>
           <a:p>
             <a:r>
-              <a:rPr lang="fr-FR" smtClean="0"/>
+              <a:rPr lang="fr-FR"/>
               <a:t>Cliquez pour modifier le style du titre</a:t>
             </a:r>
             <a:endParaRPr lang="fr-BE"/>
@@ -2622,35 +2638,35 @@
           <a:p>
             <a:pPr lvl="0"/>
             <a:r>
-              <a:rPr lang="fr-FR" smtClean="0"/>
+              <a:rPr lang="fr-FR"/>
               <a:t>Cliquez pour modifier les styles du texte du masque</a:t>
             </a:r>
           </a:p>
           <a:p>
             <a:pPr lvl="1"/>
             <a:r>
-              <a:rPr lang="fr-FR" smtClean="0"/>
+              <a:rPr lang="fr-FR"/>
               <a:t>Deuxième niveau</a:t>
             </a:r>
           </a:p>
           <a:p>
             <a:pPr lvl="2"/>
             <a:r>
-              <a:rPr lang="fr-FR" smtClean="0"/>
+              <a:rPr lang="fr-FR"/>
               <a:t>Troisième niveau</a:t>
             </a:r>
           </a:p>
           <a:p>
             <a:pPr lvl="3"/>
             <a:r>
-              <a:rPr lang="fr-FR" smtClean="0"/>
+              <a:rPr lang="fr-FR"/>
               <a:t>Quatrième niveau</a:t>
             </a:r>
           </a:p>
           <a:p>
             <a:pPr lvl="4"/>
             <a:r>
-              <a:rPr lang="fr-FR" smtClean="0"/>
+              <a:rPr lang="fr-FR"/>
               <a:t>Cinquième niveau</a:t>
             </a:r>
             <a:endParaRPr lang="fr-BE"/>
@@ -2693,7 +2709,7 @@
             <a:fld id="{AA309A6D-C09C-4548-B29A-6CF363A7E532}" type="datetimeFigureOut">
               <a:rPr lang="fr-FR" smtClean="0"/>
               <a:pPr/>
-              <a:t>25/07/2013</a:t>
+              <a:t>02/08/2025</a:t>
             </a:fld>
             <a:endParaRPr lang="fr-BE"/>
           </a:p>
@@ -3088,29 +3104,14 @@
           <a:p>
             <a:pPr algn="ctr"/>
             <a:r>
-              <a:rPr lang="fr-FR" b="1" dirty="0" smtClean="0">
+              <a:rPr lang="fr-FR" b="1" dirty="0">
                 <a:solidFill>
                   <a:schemeClr val="tx2"/>
                 </a:solidFill>
                 <a:latin typeface="Cambria" pitchFamily="18" charset="0"/>
               </a:rPr>
-              <a:t>HIRA </a:t>
-            </a:r>
-            <a:r>
-              <a:rPr lang="fr-FR" b="1" dirty="0" smtClean="0">
-                <a:solidFill>
-                  <a:schemeClr val="tx2"/>
-                </a:solidFill>
-                <a:latin typeface="Cambria" pitchFamily="18" charset="0"/>
-              </a:rPr>
-              <a:t>163</a:t>
-            </a:r>
-            <a:endParaRPr lang="fr-FR" b="1" dirty="0">
-              <a:solidFill>
-                <a:schemeClr val="tx2"/>
-              </a:solidFill>
-              <a:latin typeface="Cambria" pitchFamily="18" charset="0"/>
-            </a:endParaRPr>
+              <a:t>HIRA 163</a:t>
+            </a:r>
           </a:p>
         </p:txBody>
       </p:sp>
@@ -3140,30 +3141,30 @@
               <a:buNone/>
             </a:pPr>
             <a:r>
-              <a:rPr lang="en-US" sz="7200" dirty="0" smtClean="0">
+              <a:rPr lang="en-US" sz="7200" dirty="0">
                 <a:latin typeface="Cambria" pitchFamily="18" charset="0"/>
               </a:rPr>
               <a:t>1. He </a:t>
             </a:r>
             <a:r>
-              <a:rPr lang="en-US" sz="7200" dirty="0" err="1" smtClean="0">
+              <a:rPr lang="en-US" sz="7200" dirty="0" err="1">
                 <a:latin typeface="Cambria" pitchFamily="18" charset="0"/>
               </a:rPr>
               <a:t>Jesosy</a:t>
             </a:r>
             <a:r>
-              <a:rPr lang="en-US" sz="7200" dirty="0" smtClean="0">
+              <a:rPr lang="en-US" sz="7200" dirty="0">
                 <a:latin typeface="Cambria" pitchFamily="18" charset="0"/>
               </a:rPr>
               <a:t> </a:t>
             </a:r>
             <a:r>
-              <a:rPr lang="en-US" sz="7200" dirty="0" err="1" smtClean="0">
+              <a:rPr lang="en-US" sz="7200" dirty="0" err="1">
                 <a:latin typeface="Cambria" pitchFamily="18" charset="0"/>
               </a:rPr>
               <a:t>Tokintsika</a:t>
             </a:r>
-            <a:endParaRPr lang="fr-FR" sz="7200" dirty="0" smtClean="0">
+            <a:endParaRPr lang="fr-FR" sz="7200" dirty="0">
               <a:latin typeface="Cambria" pitchFamily="18" charset="0"/>
             </a:endParaRPr>
           </a:p>
@@ -3172,30 +3173,30 @@
               <a:buNone/>
             </a:pPr>
             <a:r>
-              <a:rPr lang="en-US" sz="7200" dirty="0" err="1" smtClean="0">
+              <a:rPr lang="en-US" sz="7200" dirty="0" err="1">
                 <a:latin typeface="Cambria" pitchFamily="18" charset="0"/>
               </a:rPr>
               <a:t>Tompon’ny</a:t>
             </a:r>
             <a:r>
-              <a:rPr lang="en-US" sz="7200" dirty="0" smtClean="0">
+              <a:rPr lang="en-US" sz="7200" dirty="0">
                 <a:latin typeface="Cambria" pitchFamily="18" charset="0"/>
               </a:rPr>
               <a:t> </a:t>
             </a:r>
             <a:r>
-              <a:rPr lang="en-US" sz="7200" dirty="0" err="1" smtClean="0">
+              <a:rPr lang="en-US" sz="7200" dirty="0" err="1">
                 <a:latin typeface="Cambria" pitchFamily="18" charset="0"/>
               </a:rPr>
               <a:t>fiainana</a:t>
             </a:r>
             <a:r>
-              <a:rPr lang="en-US" sz="7200" dirty="0" smtClean="0">
+              <a:rPr lang="en-US" sz="7200" dirty="0">
                 <a:latin typeface="Cambria" pitchFamily="18" charset="0"/>
               </a:rPr>
               <a:t>,</a:t>
             </a:r>
-            <a:endParaRPr lang="fr-FR" sz="7200" dirty="0" smtClean="0">
+            <a:endParaRPr lang="fr-FR" sz="7200" dirty="0">
               <a:latin typeface="Cambria" pitchFamily="18" charset="0"/>
             </a:endParaRPr>
           </a:p>
@@ -3204,30 +3205,30 @@
               <a:buNone/>
             </a:pPr>
             <a:r>
-              <a:rPr lang="en-US" sz="7200" dirty="0" smtClean="0">
+              <a:rPr lang="en-US" sz="7200" dirty="0">
                 <a:latin typeface="Cambria" pitchFamily="18" charset="0"/>
               </a:rPr>
               <a:t>Tonga </a:t>
             </a:r>
             <a:r>
-              <a:rPr lang="en-US" sz="7200" dirty="0" err="1" smtClean="0">
+              <a:rPr lang="en-US" sz="7200" dirty="0" err="1">
                 <a:latin typeface="Cambria" pitchFamily="18" charset="0"/>
               </a:rPr>
               <a:t>eto</a:t>
             </a:r>
             <a:r>
-              <a:rPr lang="en-US" sz="7200" dirty="0" smtClean="0">
+              <a:rPr lang="en-US" sz="7200" dirty="0">
                 <a:latin typeface="Cambria" pitchFamily="18" charset="0"/>
               </a:rPr>
               <a:t> </a:t>
             </a:r>
             <a:r>
-              <a:rPr lang="en-US" sz="7200" dirty="0" err="1" smtClean="0">
+              <a:rPr lang="en-US" sz="7200" dirty="0" err="1">
                 <a:latin typeface="Cambria" pitchFamily="18" charset="0"/>
               </a:rPr>
               <a:t>amintsika</a:t>
             </a:r>
-            <a:endParaRPr lang="fr-FR" sz="7200" dirty="0" smtClean="0">
+            <a:endParaRPr lang="fr-FR" sz="7200" dirty="0">
               <a:latin typeface="Cambria" pitchFamily="18" charset="0"/>
             </a:endParaRPr>
           </a:p>
@@ -3236,13 +3237,13 @@
               <a:buNone/>
             </a:pPr>
             <a:r>
-              <a:rPr lang="en-US" sz="7200" dirty="0" err="1" smtClean="0">
+              <a:rPr lang="en-US" sz="7200" dirty="0" err="1">
                 <a:latin typeface="Cambria" pitchFamily="18" charset="0"/>
               </a:rPr>
               <a:t>Olon-kovangiana</a:t>
             </a:r>
             <a:r>
-              <a:rPr lang="en-US" sz="7200" dirty="0" smtClean="0">
+              <a:rPr lang="en-US" sz="7200" dirty="0">
                 <a:latin typeface="Cambria" pitchFamily="18" charset="0"/>
               </a:rPr>
               <a:t>, </a:t>
@@ -3258,13 +3259,6 @@
   <p:clrMapOvr>
     <a:masterClrMapping/>
   </p:clrMapOvr>
-  <p:timing>
-    <p:tnLst>
-      <p:par>
-        <p:cTn id="1" dur="indefinite" restart="never" nodeType="tmRoot"/>
-      </p:par>
-    </p:tnLst>
-  </p:timing>
 </p:sld>
 </file>
 
@@ -3308,22 +3302,13 @@
           <a:lstStyle/>
           <a:p>
             <a:r>
-              <a:rPr lang="fr-FR" b="1" dirty="0" smtClean="0">
+              <a:rPr lang="fr-FR" b="1" dirty="0">
                 <a:solidFill>
                   <a:schemeClr val="tx2"/>
                 </a:solidFill>
                 <a:latin typeface="Cambria" pitchFamily="18" charset="0"/>
               </a:rPr>
-              <a:t>HIRA </a:t>
-            </a:r>
-            <a:r>
-              <a:rPr lang="fr-FR" b="1" dirty="0" smtClean="0">
-                <a:solidFill>
-                  <a:schemeClr val="tx2"/>
-                </a:solidFill>
-                <a:latin typeface="Cambria" pitchFamily="18" charset="0"/>
-              </a:rPr>
-              <a:t>163</a:t>
+              <a:t>HIRA 163</a:t>
             </a:r>
             <a:endParaRPr lang="fr-FR" dirty="0">
               <a:latin typeface="Cambria" pitchFamily="18" charset="0"/>
@@ -3357,36 +3342,36 @@
               <a:buNone/>
             </a:pPr>
             <a:r>
-              <a:rPr lang="en-US" sz="7200" dirty="0" err="1" smtClean="0">
+              <a:rPr lang="en-US" sz="7200" dirty="0" err="1">
                 <a:latin typeface="Cambria" pitchFamily="18" charset="0"/>
               </a:rPr>
               <a:t>Izy</a:t>
             </a:r>
             <a:r>
-              <a:rPr lang="en-US" sz="7200" dirty="0" smtClean="0">
+              <a:rPr lang="en-US" sz="7200" dirty="0">
                 <a:latin typeface="Cambria" pitchFamily="18" charset="0"/>
               </a:rPr>
               <a:t> no </a:t>
             </a:r>
             <a:r>
-              <a:rPr lang="en-US" sz="7200" dirty="0" err="1" smtClean="0">
+              <a:rPr lang="en-US" sz="7200" dirty="0" err="1">
                 <a:latin typeface="Cambria" pitchFamily="18" charset="0"/>
               </a:rPr>
               <a:t>hitory</a:t>
             </a:r>
             <a:r>
-              <a:rPr lang="en-US" sz="7200" dirty="0" smtClean="0">
+              <a:rPr lang="en-US" sz="7200" dirty="0">
                 <a:latin typeface="Cambria" pitchFamily="18" charset="0"/>
               </a:rPr>
               <a:t> </a:t>
             </a:r>
             <a:r>
-              <a:rPr lang="en-US" sz="7200" dirty="0" err="1" smtClean="0">
+              <a:rPr lang="en-US" sz="7200" dirty="0" err="1">
                 <a:latin typeface="Cambria" pitchFamily="18" charset="0"/>
               </a:rPr>
               <a:t>teny</a:t>
             </a:r>
-            <a:endParaRPr lang="en-US" sz="7200" dirty="0" smtClean="0">
+            <a:endParaRPr lang="en-US" sz="7200" dirty="0">
               <a:latin typeface="Cambria" pitchFamily="18" charset="0"/>
             </a:endParaRPr>
           </a:p>
@@ -3395,25 +3380,25 @@
               <a:buNone/>
             </a:pPr>
             <a:r>
-              <a:rPr lang="en-US" sz="7200" dirty="0" err="1" smtClean="0">
+              <a:rPr lang="en-US" sz="7200" dirty="0" err="1">
                 <a:latin typeface="Cambria" pitchFamily="18" charset="0"/>
               </a:rPr>
               <a:t>Soa</a:t>
             </a:r>
             <a:r>
-              <a:rPr lang="en-US" sz="7200" dirty="0" smtClean="0">
+              <a:rPr lang="en-US" sz="7200" dirty="0">
                 <a:latin typeface="Cambria" pitchFamily="18" charset="0"/>
               </a:rPr>
               <a:t>, </a:t>
             </a:r>
             <a:r>
-              <a:rPr lang="en-US" sz="7200" dirty="0" err="1" smtClean="0">
+              <a:rPr lang="en-US" sz="7200" dirty="0" err="1">
                 <a:latin typeface="Cambria" pitchFamily="18" charset="0"/>
               </a:rPr>
               <a:t>mahavelona</a:t>
             </a:r>
             <a:r>
-              <a:rPr lang="en-US" sz="7200" dirty="0" smtClean="0">
+              <a:rPr lang="en-US" sz="7200" dirty="0">
                 <a:latin typeface="Cambria" pitchFamily="18" charset="0"/>
               </a:rPr>
               <a:t>,</a:t>
@@ -3424,49 +3409,49 @@
               <a:buNone/>
             </a:pPr>
             <a:r>
-              <a:rPr lang="en-US" sz="7200" dirty="0" err="1" smtClean="0">
+              <a:rPr lang="en-US" sz="7200" dirty="0" err="1">
                 <a:latin typeface="Cambria" pitchFamily="18" charset="0"/>
               </a:rPr>
               <a:t>Fa</a:t>
             </a:r>
             <a:r>
-              <a:rPr lang="en-US" sz="7200" dirty="0" smtClean="0">
+              <a:rPr lang="en-US" sz="7200" dirty="0">
                 <a:latin typeface="Cambria" pitchFamily="18" charset="0"/>
               </a:rPr>
               <a:t> </a:t>
             </a:r>
             <a:r>
-              <a:rPr lang="en-US" sz="7200" dirty="0" err="1" smtClean="0">
+              <a:rPr lang="en-US" sz="7200" dirty="0" err="1">
                 <a:latin typeface="Cambria" pitchFamily="18" charset="0"/>
               </a:rPr>
               <a:t>ny</a:t>
             </a:r>
             <a:r>
-              <a:rPr lang="en-US" sz="7200" dirty="0" smtClean="0">
+              <a:rPr lang="en-US" sz="7200" dirty="0">
                 <a:latin typeface="Cambria" pitchFamily="18" charset="0"/>
               </a:rPr>
               <a:t> </a:t>
             </a:r>
             <a:r>
-              <a:rPr lang="en-US" sz="7200" dirty="0" err="1" smtClean="0">
+              <a:rPr lang="en-US" sz="7200" dirty="0" err="1">
                 <a:latin typeface="Cambria" pitchFamily="18" charset="0"/>
               </a:rPr>
               <a:t>ainy</a:t>
             </a:r>
             <a:r>
-              <a:rPr lang="en-US" sz="7200" dirty="0" smtClean="0">
+              <a:rPr lang="en-US" sz="7200" dirty="0">
                 <a:latin typeface="Cambria" pitchFamily="18" charset="0"/>
               </a:rPr>
               <a:t> no </a:t>
             </a:r>
             <a:r>
-              <a:rPr lang="en-US" sz="7200" dirty="0" err="1" smtClean="0">
+              <a:rPr lang="en-US" sz="7200" dirty="0" err="1">
                 <a:latin typeface="Cambria" pitchFamily="18" charset="0"/>
               </a:rPr>
               <a:t>nomeny</a:t>
             </a:r>
             <a:r>
-              <a:rPr lang="en-US" sz="7200" dirty="0" smtClean="0">
+              <a:rPr lang="en-US" sz="7200" dirty="0">
                 <a:latin typeface="Cambria" pitchFamily="18" charset="0"/>
               </a:rPr>
               <a:t>,</a:t>
@@ -3477,25 +3462,25 @@
               <a:buNone/>
             </a:pPr>
             <a:r>
-              <a:rPr lang="en-US" sz="7200" dirty="0" err="1" smtClean="0">
+              <a:rPr lang="en-US" sz="7200" dirty="0" err="1">
                 <a:latin typeface="Cambria" pitchFamily="18" charset="0"/>
               </a:rPr>
               <a:t>Mba</a:t>
             </a:r>
             <a:r>
-              <a:rPr lang="en-US" sz="7200" dirty="0" smtClean="0">
+              <a:rPr lang="en-US" sz="7200" dirty="0">
                 <a:latin typeface="Cambria" pitchFamily="18" charset="0"/>
               </a:rPr>
               <a:t> ho </a:t>
             </a:r>
             <a:r>
-              <a:rPr lang="en-US" sz="7200" dirty="0" err="1" smtClean="0">
+              <a:rPr lang="en-US" sz="7200" dirty="0" err="1">
                 <a:latin typeface="Cambria" pitchFamily="18" charset="0"/>
               </a:rPr>
               <a:t>solovoina</a:t>
             </a:r>
             <a:r>
-              <a:rPr lang="en-US" sz="7200" dirty="0" smtClean="0">
+              <a:rPr lang="en-US" sz="7200" dirty="0">
                 <a:latin typeface="Cambria" pitchFamily="18" charset="0"/>
               </a:rPr>
               <a:t>.</a:t>
@@ -3508,13 +3493,6 @@
   <p:clrMapOvr>
     <a:masterClrMapping/>
   </p:clrMapOvr>
-  <p:timing>
-    <p:tnLst>
-      <p:par>
-        <p:cTn id="1" dur="indefinite" restart="never" nodeType="tmRoot"/>
-      </p:par>
-    </p:tnLst>
-  </p:timing>
 </p:sld>
 </file>
 
@@ -3558,22 +3536,13 @@
           <a:lstStyle/>
           <a:p>
             <a:r>
-              <a:rPr lang="fr-FR" b="1" dirty="0" smtClean="0">
+              <a:rPr lang="fr-FR" b="1" dirty="0">
                 <a:solidFill>
                   <a:schemeClr val="tx2"/>
                 </a:solidFill>
                 <a:latin typeface="Cambria" pitchFamily="18" charset="0"/>
               </a:rPr>
-              <a:t>HIRA </a:t>
-            </a:r>
-            <a:r>
-              <a:rPr lang="fr-FR" b="1" dirty="0" smtClean="0">
-                <a:solidFill>
-                  <a:schemeClr val="tx2"/>
-                </a:solidFill>
-                <a:latin typeface="Cambria" pitchFamily="18" charset="0"/>
-              </a:rPr>
-              <a:t>163</a:t>
+              <a:t>HIRA 163</a:t>
             </a:r>
             <a:endParaRPr lang="fr-FR" dirty="0">
               <a:latin typeface="Cambria" pitchFamily="18" charset="0"/>
@@ -3607,30 +3576,30 @@
               <a:buNone/>
             </a:pPr>
             <a:r>
-              <a:rPr lang="en-US" sz="6600" dirty="0" smtClean="0">
+              <a:rPr lang="en-US" sz="6600" dirty="0">
                 <a:latin typeface="Cambria" pitchFamily="18" charset="0"/>
               </a:rPr>
               <a:t>2. </a:t>
             </a:r>
             <a:r>
-              <a:rPr lang="en-US" sz="6600" dirty="0" err="1" smtClean="0">
+              <a:rPr lang="en-US" sz="6600" dirty="0" err="1">
                 <a:latin typeface="Cambria" pitchFamily="18" charset="0"/>
               </a:rPr>
               <a:t>Andrandraonao</a:t>
             </a:r>
             <a:r>
-              <a:rPr lang="en-US" sz="6600" dirty="0" smtClean="0">
+              <a:rPr lang="en-US" sz="6600" dirty="0">
                 <a:latin typeface="Cambria" pitchFamily="18" charset="0"/>
               </a:rPr>
               <a:t> ka </a:t>
             </a:r>
             <a:r>
-              <a:rPr lang="en-US" sz="6600" dirty="0" err="1" smtClean="0">
+              <a:rPr lang="en-US" sz="6600" dirty="0" err="1">
                 <a:latin typeface="Cambria" pitchFamily="18" charset="0"/>
               </a:rPr>
               <a:t>andraso</a:t>
             </a:r>
-            <a:endParaRPr lang="en-US" sz="6600" dirty="0" smtClean="0">
+            <a:endParaRPr lang="en-US" sz="6600" dirty="0">
               <a:latin typeface="Cambria" pitchFamily="18" charset="0"/>
             </a:endParaRPr>
           </a:p>
@@ -3639,37 +3608,37 @@
               <a:buNone/>
             </a:pPr>
             <a:r>
-              <a:rPr lang="en-US" sz="6600" dirty="0" err="1" smtClean="0">
+              <a:rPr lang="en-US" sz="6600" dirty="0" err="1">
                 <a:latin typeface="Cambria" pitchFamily="18" charset="0"/>
               </a:rPr>
               <a:t>Ny</a:t>
             </a:r>
             <a:r>
-              <a:rPr lang="en-US" sz="6600" dirty="0" smtClean="0">
+              <a:rPr lang="en-US" sz="6600" dirty="0">
                 <a:latin typeface="Cambria" pitchFamily="18" charset="0"/>
               </a:rPr>
               <a:t> </a:t>
             </a:r>
             <a:r>
-              <a:rPr lang="en-US" sz="6600" dirty="0" err="1" smtClean="0">
+              <a:rPr lang="en-US" sz="6600" dirty="0" err="1">
                 <a:latin typeface="Cambria" pitchFamily="18" charset="0"/>
               </a:rPr>
               <a:t>Mazava</a:t>
             </a:r>
             <a:r>
-              <a:rPr lang="en-US" sz="6600" dirty="0" smtClean="0">
+              <a:rPr lang="en-US" sz="6600" dirty="0">
                 <a:latin typeface="Cambria" pitchFamily="18" charset="0"/>
               </a:rPr>
               <a:t> </a:t>
             </a:r>
             <a:r>
-              <a:rPr lang="en-US" sz="6600" dirty="0" err="1" smtClean="0">
+              <a:rPr lang="en-US" sz="6600" dirty="0" err="1">
                 <a:latin typeface="Cambria" pitchFamily="18" charset="0"/>
               </a:rPr>
               <a:t>lehibe</a:t>
             </a:r>
             <a:r>
-              <a:rPr lang="en-US" sz="6600" dirty="0" smtClean="0">
+              <a:rPr lang="en-US" sz="6600" dirty="0">
                 <a:latin typeface="Cambria" pitchFamily="18" charset="0"/>
               </a:rPr>
               <a:t>!</a:t>
@@ -3680,61 +3649,61 @@
               <a:buNone/>
             </a:pPr>
             <a:r>
-              <a:rPr lang="en-US" sz="6600" dirty="0" err="1" smtClean="0">
+              <a:rPr lang="en-US" sz="6600" dirty="0" err="1">
                 <a:latin typeface="Cambria" pitchFamily="18" charset="0"/>
               </a:rPr>
               <a:t>Dia</a:t>
             </a:r>
             <a:r>
-              <a:rPr lang="en-US" sz="6600" dirty="0" smtClean="0">
+              <a:rPr lang="en-US" sz="6600" dirty="0">
                 <a:latin typeface="Cambria" pitchFamily="18" charset="0"/>
               </a:rPr>
               <a:t> </a:t>
             </a:r>
             <a:r>
-              <a:rPr lang="en-US" sz="6600" dirty="0" err="1" smtClean="0">
+              <a:rPr lang="en-US" sz="6600" dirty="0" err="1">
                 <a:latin typeface="Cambria" pitchFamily="18" charset="0"/>
               </a:rPr>
               <a:t>Ilay</a:t>
             </a:r>
             <a:r>
-              <a:rPr lang="en-US" sz="6600" dirty="0" smtClean="0">
+              <a:rPr lang="en-US" sz="6600" dirty="0">
                 <a:latin typeface="Cambria" pitchFamily="18" charset="0"/>
               </a:rPr>
               <a:t> </a:t>
             </a:r>
             <a:r>
-              <a:rPr lang="en-US" sz="6600" dirty="0" err="1" smtClean="0">
+              <a:rPr lang="en-US" sz="6600" dirty="0" err="1">
                 <a:latin typeface="Cambria" pitchFamily="18" charset="0"/>
               </a:rPr>
               <a:t>tsy</a:t>
             </a:r>
             <a:r>
-              <a:rPr lang="en-US" sz="6600" dirty="0" smtClean="0">
+              <a:rPr lang="en-US" sz="6600" dirty="0">
                 <a:latin typeface="Cambria" pitchFamily="18" charset="0"/>
               </a:rPr>
               <a:t> </a:t>
             </a:r>
             <a:r>
-              <a:rPr lang="en-US" sz="6600" dirty="0" err="1" smtClean="0">
+              <a:rPr lang="en-US" sz="6600" dirty="0" err="1">
                 <a:latin typeface="Cambria" pitchFamily="18" charset="0"/>
               </a:rPr>
               <a:t>hita</a:t>
             </a:r>
             <a:r>
-              <a:rPr lang="en-US" sz="6600" dirty="0" smtClean="0">
+              <a:rPr lang="en-US" sz="6600" dirty="0">
                 <a:latin typeface="Cambria" pitchFamily="18" charset="0"/>
               </a:rPr>
               <a:t> </a:t>
             </a:r>
             <a:r>
-              <a:rPr lang="en-US" sz="6600" dirty="0" err="1" smtClean="0">
+              <a:rPr lang="en-US" sz="6600" dirty="0" err="1">
                 <a:latin typeface="Cambria" pitchFamily="18" charset="0"/>
               </a:rPr>
               <a:t>maso</a:t>
             </a:r>
             <a:r>
-              <a:rPr lang="en-US" sz="6600" dirty="0" smtClean="0">
+              <a:rPr lang="en-US" sz="6600" dirty="0">
                 <a:latin typeface="Cambria" pitchFamily="18" charset="0"/>
               </a:rPr>
               <a:t>,</a:t>
@@ -3745,25 +3714,25 @@
               <a:buNone/>
             </a:pPr>
             <a:r>
-              <a:rPr lang="en-US" sz="6600" dirty="0" err="1" smtClean="0">
+              <a:rPr lang="en-US" sz="6600" dirty="0" err="1">
                 <a:latin typeface="Cambria" pitchFamily="18" charset="0"/>
               </a:rPr>
               <a:t>Mpanazava</a:t>
             </a:r>
             <a:r>
-              <a:rPr lang="en-US" sz="6600" dirty="0" smtClean="0">
+              <a:rPr lang="en-US" sz="6600" dirty="0">
                 <a:latin typeface="Cambria" pitchFamily="18" charset="0"/>
               </a:rPr>
               <a:t>, </a:t>
             </a:r>
             <a:r>
-              <a:rPr lang="en-US" sz="6600" dirty="0" err="1" smtClean="0">
+              <a:rPr lang="en-US" sz="6600" dirty="0" err="1">
                 <a:latin typeface="Cambria" pitchFamily="18" charset="0"/>
               </a:rPr>
               <a:t>Mpanome</a:t>
             </a:r>
             <a:r>
-              <a:rPr lang="en-US" sz="6600" dirty="0" smtClean="0">
+              <a:rPr lang="en-US" sz="6600" dirty="0">
                 <a:latin typeface="Cambria" pitchFamily="18" charset="0"/>
               </a:rPr>
               <a:t>; </a:t>
@@ -3776,13 +3745,6 @@
   <p:clrMapOvr>
     <a:masterClrMapping/>
   </p:clrMapOvr>
-  <p:timing>
-    <p:tnLst>
-      <p:par>
-        <p:cTn id="1" dur="indefinite" restart="never" nodeType="tmRoot"/>
-      </p:par>
-    </p:tnLst>
-  </p:timing>
 </p:sld>
 </file>
 
@@ -3826,7 +3788,7 @@
           <a:lstStyle/>
           <a:p>
             <a:r>
-              <a:rPr lang="fr-FR" b="1" dirty="0" smtClean="0">
+              <a:rPr lang="fr-FR" b="1" dirty="0">
                 <a:solidFill>
                   <a:schemeClr val="tx2"/>
                 </a:solidFill>
@@ -3866,49 +3828,49 @@
               <a:buNone/>
             </a:pPr>
             <a:r>
-              <a:rPr lang="en-US" sz="6600" dirty="0" err="1" smtClean="0">
+              <a:rPr lang="en-US" sz="6600" dirty="0" err="1">
                 <a:latin typeface="Cambria" pitchFamily="18" charset="0"/>
               </a:rPr>
               <a:t>Fa</a:t>
             </a:r>
             <a:r>
-              <a:rPr lang="en-US" sz="6600" dirty="0" smtClean="0">
+              <a:rPr lang="en-US" sz="6600" dirty="0">
                 <a:latin typeface="Cambria" pitchFamily="18" charset="0"/>
               </a:rPr>
               <a:t> </a:t>
             </a:r>
             <a:r>
-              <a:rPr lang="en-US" sz="6600" dirty="0" err="1" smtClean="0">
+              <a:rPr lang="en-US" sz="6600" dirty="0" err="1">
                 <a:latin typeface="Cambria" pitchFamily="18" charset="0"/>
               </a:rPr>
               <a:t>ny</a:t>
             </a:r>
             <a:r>
-              <a:rPr lang="en-US" sz="6600" dirty="0" smtClean="0">
+              <a:rPr lang="en-US" sz="6600" dirty="0">
                 <a:latin typeface="Cambria" pitchFamily="18" charset="0"/>
               </a:rPr>
               <a:t> </a:t>
             </a:r>
             <a:r>
-              <a:rPr lang="en-US" sz="6600" dirty="0" err="1" smtClean="0">
+              <a:rPr lang="en-US" sz="6600" dirty="0" err="1">
                 <a:latin typeface="Cambria" pitchFamily="18" charset="0"/>
               </a:rPr>
               <a:t>ainao</a:t>
             </a:r>
             <a:r>
-              <a:rPr lang="en-US" sz="6600" dirty="0" smtClean="0">
+              <a:rPr lang="en-US" sz="6600" dirty="0">
                 <a:latin typeface="Cambria" pitchFamily="18" charset="0"/>
               </a:rPr>
               <a:t> </a:t>
             </a:r>
             <a:r>
-              <a:rPr lang="en-US" sz="6600" dirty="0" err="1" smtClean="0">
+              <a:rPr lang="en-US" sz="6600" dirty="0" err="1">
                 <a:latin typeface="Cambria" pitchFamily="18" charset="0"/>
               </a:rPr>
               <a:t>dia</a:t>
             </a:r>
             <a:r>
-              <a:rPr lang="en-US" sz="6600" dirty="0" smtClean="0">
+              <a:rPr lang="en-US" sz="6600" dirty="0">
                 <a:latin typeface="Cambria" pitchFamily="18" charset="0"/>
               </a:rPr>
               <a:t> ho very,</a:t>
@@ -3919,36 +3881,36 @@
               <a:buNone/>
             </a:pPr>
             <a:r>
-              <a:rPr lang="en-US" sz="6600" dirty="0" err="1" smtClean="0">
+              <a:rPr lang="en-US" sz="6600" dirty="0" err="1">
                 <a:latin typeface="Cambria" pitchFamily="18" charset="0"/>
               </a:rPr>
               <a:t>Raha</a:t>
             </a:r>
             <a:r>
-              <a:rPr lang="en-US" sz="6600" dirty="0" smtClean="0">
+              <a:rPr lang="en-US" sz="6600" dirty="0">
                 <a:latin typeface="Cambria" pitchFamily="18" charset="0"/>
               </a:rPr>
               <a:t> </a:t>
             </a:r>
             <a:r>
-              <a:rPr lang="en-US" sz="6600" dirty="0" err="1" smtClean="0">
+              <a:rPr lang="en-US" sz="6600" dirty="0" err="1">
                 <a:latin typeface="Cambria" pitchFamily="18" charset="0"/>
               </a:rPr>
               <a:t>tsy</a:t>
             </a:r>
             <a:r>
-              <a:rPr lang="en-US" sz="6600" dirty="0" smtClean="0">
+              <a:rPr lang="en-US" sz="6600" dirty="0">
                 <a:latin typeface="Cambria" pitchFamily="18" charset="0"/>
               </a:rPr>
               <a:t> </a:t>
             </a:r>
             <a:r>
-              <a:rPr lang="en-US" sz="6600" dirty="0" err="1" smtClean="0">
+              <a:rPr lang="en-US" sz="6600" dirty="0" err="1">
                 <a:latin typeface="Cambria" pitchFamily="18" charset="0"/>
               </a:rPr>
               <a:t>arahinao</a:t>
             </a:r>
-            <a:endParaRPr lang="en-US" sz="6600" dirty="0" smtClean="0">
+            <a:endParaRPr lang="en-US" sz="6600" dirty="0">
               <a:latin typeface="Cambria" pitchFamily="18" charset="0"/>
             </a:endParaRPr>
           </a:p>
@@ -3957,36 +3919,36 @@
               <a:buNone/>
             </a:pPr>
             <a:r>
-              <a:rPr lang="en-US" sz="6600" dirty="0" err="1" smtClean="0">
+              <a:rPr lang="en-US" sz="6600" dirty="0" err="1">
                 <a:latin typeface="Cambria" pitchFamily="18" charset="0"/>
               </a:rPr>
               <a:t>Ilay</a:t>
             </a:r>
             <a:r>
-              <a:rPr lang="en-US" sz="6600" dirty="0" smtClean="0">
+              <a:rPr lang="en-US" sz="6600" dirty="0">
                 <a:latin typeface="Cambria" pitchFamily="18" charset="0"/>
               </a:rPr>
               <a:t> </a:t>
             </a:r>
             <a:r>
-              <a:rPr lang="en-US" sz="6600" dirty="0" err="1" smtClean="0">
+              <a:rPr lang="en-US" sz="6600" dirty="0" err="1">
                 <a:latin typeface="Cambria" pitchFamily="18" charset="0"/>
               </a:rPr>
               <a:t>Mpanjaka</a:t>
             </a:r>
             <a:r>
-              <a:rPr lang="en-US" sz="6600" dirty="0" smtClean="0">
+              <a:rPr lang="en-US" sz="6600" dirty="0">
                 <a:latin typeface="Cambria" pitchFamily="18" charset="0"/>
               </a:rPr>
               <a:t> </a:t>
             </a:r>
             <a:r>
-              <a:rPr lang="en-US" sz="6600" dirty="0" err="1" smtClean="0">
+              <a:rPr lang="en-US" sz="6600" dirty="0" err="1">
                 <a:latin typeface="Cambria" pitchFamily="18" charset="0"/>
               </a:rPr>
               <a:t>manan-kery</a:t>
             </a:r>
-            <a:endParaRPr lang="en-US" sz="6600" dirty="0" smtClean="0">
+            <a:endParaRPr lang="en-US" sz="6600" dirty="0">
               <a:latin typeface="Cambria" pitchFamily="18" charset="0"/>
             </a:endParaRPr>
           </a:p>
@@ -3995,37 +3957,37 @@
               <a:buNone/>
             </a:pPr>
             <a:r>
-              <a:rPr lang="en-US" sz="6600" dirty="0" err="1" smtClean="0">
+              <a:rPr lang="en-US" sz="6600" dirty="0" err="1">
                 <a:latin typeface="Cambria" pitchFamily="18" charset="0"/>
               </a:rPr>
               <a:t>Izay</a:t>
             </a:r>
             <a:r>
-              <a:rPr lang="en-US" sz="6600" dirty="0" smtClean="0">
+              <a:rPr lang="en-US" sz="6600" dirty="0">
                 <a:latin typeface="Cambria" pitchFamily="18" charset="0"/>
               </a:rPr>
               <a:t> </a:t>
             </a:r>
             <a:r>
-              <a:rPr lang="en-US" sz="6600" dirty="0" err="1" smtClean="0">
+              <a:rPr lang="en-US" sz="6600" dirty="0" err="1">
                 <a:latin typeface="Cambria" pitchFamily="18" charset="0"/>
               </a:rPr>
               <a:t>nanavotra</a:t>
             </a:r>
             <a:r>
-              <a:rPr lang="en-US" sz="6600" dirty="0" smtClean="0">
+              <a:rPr lang="en-US" sz="6600" dirty="0">
                 <a:latin typeface="Cambria" pitchFamily="18" charset="0"/>
               </a:rPr>
               <a:t> </a:t>
             </a:r>
             <a:r>
-              <a:rPr lang="en-US" sz="6600" dirty="0" err="1" smtClean="0">
+              <a:rPr lang="en-US" sz="6600" dirty="0" err="1">
                 <a:latin typeface="Cambria" pitchFamily="18" charset="0"/>
               </a:rPr>
               <a:t>anao</a:t>
             </a:r>
             <a:r>
-              <a:rPr lang="en-US" sz="6600" dirty="0" smtClean="0">
+              <a:rPr lang="en-US" sz="6600" dirty="0">
                 <a:latin typeface="Cambria" pitchFamily="18" charset="0"/>
               </a:rPr>
               <a:t>.</a:t>
@@ -4038,13 +4000,6 @@
   <p:clrMapOvr>
     <a:masterClrMapping/>
   </p:clrMapOvr>
-  <p:timing>
-    <p:tnLst>
-      <p:par>
-        <p:cTn id="1" dur="indefinite" restart="never" nodeType="tmRoot"/>
-      </p:par>
-    </p:tnLst>
-  </p:timing>
 </p:sld>
 </file>
 
@@ -4088,7 +4043,7 @@
           <a:lstStyle/>
           <a:p>
             <a:r>
-              <a:rPr lang="fr-FR" b="1" dirty="0" smtClean="0">
+              <a:rPr lang="fr-FR" b="1" dirty="0">
                 <a:solidFill>
                   <a:schemeClr val="tx2"/>
                 </a:solidFill>
@@ -4128,30 +4083,30 @@
               <a:buNone/>
             </a:pPr>
             <a:r>
-              <a:rPr lang="en-US" sz="7200" dirty="0" smtClean="0">
-                <a:latin typeface="Cambria" pitchFamily="18" charset="0"/>
-              </a:rPr>
-              <a:t>3 </a:t>
-            </a:r>
-            <a:r>
-              <a:rPr lang="en-US" sz="7200" dirty="0" err="1" smtClean="0">
+              <a:rPr lang="en-US" sz="7200">
+                <a:latin typeface="Cambria" pitchFamily="18" charset="0"/>
+              </a:rPr>
+              <a:t>3. </a:t>
+            </a:r>
+            <a:r>
+              <a:rPr lang="en-US" sz="7200" dirty="0" err="1">
                 <a:latin typeface="Cambria" pitchFamily="18" charset="0"/>
               </a:rPr>
               <a:t>Eto</a:t>
             </a:r>
             <a:r>
-              <a:rPr lang="en-US" sz="7200" dirty="0" smtClean="0">
+              <a:rPr lang="en-US" sz="7200" dirty="0">
                 <a:latin typeface="Cambria" pitchFamily="18" charset="0"/>
               </a:rPr>
               <a:t> </a:t>
             </a:r>
             <a:r>
-              <a:rPr lang="en-US" sz="7200" dirty="0" err="1" smtClean="0">
+              <a:rPr lang="en-US" sz="7200" dirty="0" err="1">
                 <a:latin typeface="Cambria" pitchFamily="18" charset="0"/>
               </a:rPr>
               <a:t>afovoantsika</a:t>
             </a:r>
-            <a:endParaRPr lang="en-US" sz="7200" dirty="0" smtClean="0">
+            <a:endParaRPr lang="en-US" sz="7200" dirty="0">
               <a:latin typeface="Cambria" pitchFamily="18" charset="0"/>
             </a:endParaRPr>
           </a:p>
@@ -4160,37 +4115,37 @@
               <a:buNone/>
             </a:pPr>
             <a:r>
-              <a:rPr lang="en-US" sz="7200" dirty="0" err="1" smtClean="0">
+              <a:rPr lang="en-US" sz="7200" dirty="0" err="1">
                 <a:latin typeface="Cambria" pitchFamily="18" charset="0"/>
               </a:rPr>
               <a:t>Ilay</a:t>
             </a:r>
             <a:r>
-              <a:rPr lang="en-US" sz="7200" dirty="0" smtClean="0">
+              <a:rPr lang="en-US" sz="7200" dirty="0">
                 <a:latin typeface="Cambria" pitchFamily="18" charset="0"/>
               </a:rPr>
               <a:t> </a:t>
             </a:r>
             <a:r>
-              <a:rPr lang="en-US" sz="7200" dirty="0" err="1" smtClean="0">
+              <a:rPr lang="en-US" sz="7200" dirty="0" err="1">
                 <a:latin typeface="Cambria" pitchFamily="18" charset="0"/>
               </a:rPr>
               <a:t>Mazava</a:t>
             </a:r>
             <a:r>
-              <a:rPr lang="en-US" sz="7200" dirty="0" smtClean="0">
+              <a:rPr lang="en-US" sz="7200" dirty="0">
                 <a:latin typeface="Cambria" pitchFamily="18" charset="0"/>
               </a:rPr>
               <a:t> </a:t>
             </a:r>
             <a:r>
-              <a:rPr lang="en-US" sz="7200" dirty="0" err="1" smtClean="0">
+              <a:rPr lang="en-US" sz="7200" dirty="0" err="1">
                 <a:latin typeface="Cambria" pitchFamily="18" charset="0"/>
               </a:rPr>
               <a:t>tokana</a:t>
             </a:r>
             <a:r>
-              <a:rPr lang="en-US" sz="7200" dirty="0" smtClean="0">
+              <a:rPr lang="en-US" sz="7200" dirty="0">
                 <a:latin typeface="Cambria" pitchFamily="18" charset="0"/>
               </a:rPr>
               <a:t>;</a:t>
@@ -4201,36 +4156,36 @@
               <a:buNone/>
             </a:pPr>
             <a:r>
-              <a:rPr lang="en-US" sz="7200" dirty="0" err="1" smtClean="0">
+              <a:rPr lang="en-US" sz="7200" dirty="0" err="1">
                 <a:latin typeface="Cambria" pitchFamily="18" charset="0"/>
               </a:rPr>
               <a:t>Sambatra</a:t>
             </a:r>
             <a:r>
-              <a:rPr lang="en-US" sz="7200" dirty="0" smtClean="0">
+              <a:rPr lang="en-US" sz="7200" dirty="0">
                 <a:latin typeface="Cambria" pitchFamily="18" charset="0"/>
               </a:rPr>
               <a:t> </a:t>
             </a:r>
             <a:r>
-              <a:rPr lang="en-US" sz="7200" dirty="0" err="1" smtClean="0">
+              <a:rPr lang="en-US" sz="7200" dirty="0" err="1">
                 <a:latin typeface="Cambria" pitchFamily="18" charset="0"/>
               </a:rPr>
               <a:t>izay</a:t>
             </a:r>
             <a:r>
-              <a:rPr lang="en-US" sz="7200" dirty="0" smtClean="0">
+              <a:rPr lang="en-US" sz="7200" dirty="0">
                 <a:latin typeface="Cambria" pitchFamily="18" charset="0"/>
               </a:rPr>
               <a:t> </a:t>
             </a:r>
             <a:r>
-              <a:rPr lang="en-US" sz="7200" dirty="0" err="1" smtClean="0">
+              <a:rPr lang="en-US" sz="7200" dirty="0" err="1">
                 <a:latin typeface="Cambria" pitchFamily="18" charset="0"/>
               </a:rPr>
               <a:t>mahita</a:t>
             </a:r>
-            <a:endParaRPr lang="en-US" sz="7200" dirty="0" smtClean="0">
+            <a:endParaRPr lang="en-US" sz="7200" dirty="0">
               <a:latin typeface="Cambria" pitchFamily="18" charset="0"/>
             </a:endParaRPr>
           </a:p>
@@ -4239,37 +4194,37 @@
               <a:buNone/>
             </a:pPr>
             <a:r>
-              <a:rPr lang="en-US" sz="7200" dirty="0" err="1" smtClean="0">
+              <a:rPr lang="en-US" sz="7200" dirty="0" err="1">
                 <a:latin typeface="Cambria" pitchFamily="18" charset="0"/>
               </a:rPr>
               <a:t>Azy</a:t>
             </a:r>
             <a:r>
-              <a:rPr lang="en-US" sz="7200" dirty="0" smtClean="0">
+              <a:rPr lang="en-US" sz="7200" dirty="0">
                 <a:latin typeface="Cambria" pitchFamily="18" charset="0"/>
               </a:rPr>
               <a:t>, </a:t>
             </a:r>
             <a:r>
-              <a:rPr lang="en-US" sz="7200" dirty="0" err="1" smtClean="0">
+              <a:rPr lang="en-US" sz="7200" dirty="0" err="1">
                 <a:latin typeface="Cambria" pitchFamily="18" charset="0"/>
               </a:rPr>
               <a:t>fa</a:t>
             </a:r>
             <a:r>
-              <a:rPr lang="en-US" sz="7200" dirty="0" smtClean="0">
+              <a:rPr lang="en-US" sz="7200" dirty="0">
                 <a:latin typeface="Cambria" pitchFamily="18" charset="0"/>
               </a:rPr>
               <a:t> ho </a:t>
             </a:r>
             <a:r>
-              <a:rPr lang="en-US" sz="7200" dirty="0" err="1" smtClean="0">
+              <a:rPr lang="en-US" sz="7200" dirty="0" err="1">
                 <a:latin typeface="Cambria" pitchFamily="18" charset="0"/>
               </a:rPr>
               <a:t>velona</a:t>
             </a:r>
             <a:r>
-              <a:rPr lang="en-US" sz="7200" dirty="0" smtClean="0">
+              <a:rPr lang="en-US" sz="7200" dirty="0">
                 <a:latin typeface="Cambria" pitchFamily="18" charset="0"/>
               </a:rPr>
               <a:t>.</a:t>
@@ -4282,13 +4237,6 @@
   <p:clrMapOvr>
     <a:masterClrMapping/>
   </p:clrMapOvr>
-  <p:timing>
-    <p:tnLst>
-      <p:par>
-        <p:cTn id="1" dur="indefinite" restart="never" nodeType="tmRoot"/>
-      </p:par>
-    </p:tnLst>
-  </p:timing>
 </p:sld>
 </file>
 
@@ -4332,7 +4280,7 @@
           <a:lstStyle/>
           <a:p>
             <a:r>
-              <a:rPr lang="fr-FR" b="1" smtClean="0">
+              <a:rPr lang="fr-FR" b="1">
                 <a:solidFill>
                   <a:schemeClr val="tx2"/>
                 </a:solidFill>
@@ -4372,36 +4320,36 @@
               <a:buNone/>
             </a:pPr>
             <a:r>
-              <a:rPr lang="en-US" sz="7200" dirty="0" err="1" smtClean="0">
+              <a:rPr lang="en-US" sz="7200" dirty="0" err="1">
                 <a:latin typeface="Cambria" pitchFamily="18" charset="0"/>
               </a:rPr>
               <a:t>Ry</a:t>
             </a:r>
             <a:r>
-              <a:rPr lang="en-US" sz="7200" dirty="0" smtClean="0">
+              <a:rPr lang="en-US" sz="7200" dirty="0">
                 <a:latin typeface="Cambria" pitchFamily="18" charset="0"/>
               </a:rPr>
               <a:t> </a:t>
             </a:r>
             <a:r>
-              <a:rPr lang="en-US" sz="7200" dirty="0" err="1" smtClean="0">
+              <a:rPr lang="en-US" sz="7200" dirty="0" err="1">
                 <a:latin typeface="Cambria" pitchFamily="18" charset="0"/>
               </a:rPr>
               <a:t>Jesosy</a:t>
             </a:r>
             <a:r>
-              <a:rPr lang="en-US" sz="7200" dirty="0" smtClean="0">
+              <a:rPr lang="en-US" sz="7200" dirty="0">
                 <a:latin typeface="Cambria" pitchFamily="18" charset="0"/>
               </a:rPr>
               <a:t>, </a:t>
             </a:r>
             <a:r>
-              <a:rPr lang="en-US" sz="7200" dirty="0" err="1" smtClean="0">
+              <a:rPr lang="en-US" sz="7200" dirty="0" err="1">
                 <a:latin typeface="Cambria" pitchFamily="18" charset="0"/>
               </a:rPr>
               <a:t>iresaho</a:t>
             </a:r>
-            <a:endParaRPr lang="en-US" sz="7200" dirty="0" smtClean="0">
+            <a:endParaRPr lang="en-US" sz="7200" dirty="0">
               <a:latin typeface="Cambria" pitchFamily="18" charset="0"/>
             </a:endParaRPr>
           </a:p>
@@ -4410,25 +4358,25 @@
               <a:buNone/>
             </a:pPr>
             <a:r>
-              <a:rPr lang="en-US" sz="7200" dirty="0" err="1" smtClean="0">
+              <a:rPr lang="en-US" sz="7200" dirty="0" err="1">
                 <a:latin typeface="Cambria" pitchFamily="18" charset="0"/>
               </a:rPr>
               <a:t>Izahay</a:t>
             </a:r>
             <a:r>
-              <a:rPr lang="en-US" sz="7200" dirty="0" smtClean="0">
+              <a:rPr lang="en-US" sz="7200" dirty="0">
                 <a:latin typeface="Cambria" pitchFamily="18" charset="0"/>
               </a:rPr>
               <a:t> </a:t>
             </a:r>
             <a:r>
-              <a:rPr lang="en-US" sz="7200" dirty="0" err="1" smtClean="0">
+              <a:rPr lang="en-US" sz="7200" dirty="0" err="1">
                 <a:latin typeface="Cambria" pitchFamily="18" charset="0"/>
               </a:rPr>
               <a:t>mpianatrao</a:t>
             </a:r>
             <a:r>
-              <a:rPr lang="en-US" sz="7200" dirty="0" smtClean="0">
+              <a:rPr lang="en-US" sz="7200" dirty="0">
                 <a:latin typeface="Cambria" pitchFamily="18" charset="0"/>
               </a:rPr>
               <a:t>,</a:t>
@@ -4439,36 +4387,36 @@
               <a:buNone/>
             </a:pPr>
             <a:r>
-              <a:rPr lang="en-US" sz="7200" dirty="0" err="1" smtClean="0">
+              <a:rPr lang="en-US" sz="7200" dirty="0" err="1">
                 <a:latin typeface="Cambria" pitchFamily="18" charset="0"/>
               </a:rPr>
               <a:t>Hafanao</a:t>
             </a:r>
             <a:r>
-              <a:rPr lang="en-US" sz="7200" dirty="0" smtClean="0">
+              <a:rPr lang="en-US" sz="7200" dirty="0">
                 <a:latin typeface="Cambria" pitchFamily="18" charset="0"/>
               </a:rPr>
               <a:t> </a:t>
             </a:r>
             <a:r>
-              <a:rPr lang="en-US" sz="7200" dirty="0" err="1" smtClean="0">
+              <a:rPr lang="en-US" sz="7200" dirty="0" err="1">
                 <a:latin typeface="Cambria" pitchFamily="18" charset="0"/>
               </a:rPr>
               <a:t>sy</a:t>
             </a:r>
             <a:r>
-              <a:rPr lang="en-US" sz="7200" dirty="0" smtClean="0">
+              <a:rPr lang="en-US" sz="7200" dirty="0">
                 <a:latin typeface="Cambria" pitchFamily="18" charset="0"/>
               </a:rPr>
               <a:t> </a:t>
             </a:r>
             <a:r>
-              <a:rPr lang="en-US" sz="7200" dirty="0" err="1" smtClean="0">
+              <a:rPr lang="en-US" sz="7200" dirty="0" err="1">
                 <a:latin typeface="Cambria" pitchFamily="18" charset="0"/>
               </a:rPr>
               <a:t>hatanjaho</a:t>
             </a:r>
-            <a:endParaRPr lang="en-US" sz="7200" dirty="0" smtClean="0">
+            <a:endParaRPr lang="en-US" sz="7200" dirty="0">
               <a:latin typeface="Cambria" pitchFamily="18" charset="0"/>
             </a:endParaRPr>
           </a:p>
@@ -4477,37 +4425,37 @@
               <a:buNone/>
             </a:pPr>
             <a:r>
-              <a:rPr lang="en-US" sz="7200" dirty="0" err="1" smtClean="0">
+              <a:rPr lang="en-US" sz="7200" dirty="0" err="1">
                 <a:latin typeface="Cambria" pitchFamily="18" charset="0"/>
               </a:rPr>
               <a:t>Ny</a:t>
             </a:r>
             <a:r>
-              <a:rPr lang="en-US" sz="7200" dirty="0" smtClean="0">
+              <a:rPr lang="en-US" sz="7200" dirty="0">
                 <a:latin typeface="Cambria" pitchFamily="18" charset="0"/>
               </a:rPr>
               <a:t> </a:t>
             </a:r>
             <a:r>
-              <a:rPr lang="en-US" sz="7200" dirty="0" err="1" smtClean="0">
+              <a:rPr lang="en-US" sz="7200" dirty="0" err="1">
                 <a:latin typeface="Cambria" pitchFamily="18" charset="0"/>
               </a:rPr>
               <a:t>finoanay</a:t>
             </a:r>
             <a:r>
-              <a:rPr lang="en-US" sz="7200" dirty="0" smtClean="0">
+              <a:rPr lang="en-US" sz="7200" dirty="0">
                 <a:latin typeface="Cambria" pitchFamily="18" charset="0"/>
               </a:rPr>
               <a:t> </a:t>
             </a:r>
             <a:r>
-              <a:rPr lang="en-US" sz="7200" dirty="0" err="1" smtClean="0">
+              <a:rPr lang="en-US" sz="7200" dirty="0" err="1">
                 <a:latin typeface="Cambria" pitchFamily="18" charset="0"/>
               </a:rPr>
               <a:t>Anao</a:t>
             </a:r>
             <a:r>
-              <a:rPr lang="en-US" sz="7200" dirty="0" smtClean="0">
+              <a:rPr lang="en-US" sz="7200" dirty="0">
                 <a:latin typeface="Cambria" pitchFamily="18" charset="0"/>
               </a:rPr>
               <a:t>.</a:t>
@@ -4518,7 +4466,7 @@
               <a:buNone/>
             </a:pPr>
             <a:r>
-              <a:rPr lang="en-US" sz="7200" dirty="0" smtClean="0">
+              <a:rPr lang="en-US" sz="7200" dirty="0">
                 <a:latin typeface="Cambria" pitchFamily="18" charset="0"/>
               </a:rPr>
               <a:t> </a:t>
@@ -4531,13 +4479,6 @@
   <p:clrMapOvr>
     <a:masterClrMapping/>
   </p:clrMapOvr>
-  <p:timing>
-    <p:tnLst>
-      <p:par>
-        <p:cTn id="1" dur="indefinite" restart="never" nodeType="tmRoot"/>
-      </p:par>
-    </p:tnLst>
-  </p:timing>
 </p:sld>
 </file>
 

</xml_diff>